<commit_message>
docs: adjust font sizing and expand Phase 2 details
- Reduce default bullet base size from 28 to 22 and adjust level scaling
- Make line spacing more compact (1.1) to prevent text overflow
- Expand Phase 2 content into granular data collection, training, and deployment tasks
</commit_message>
<xml_diff>
--- a/docs/RJ2506_Architecture_V3.pptx
+++ b/docs/RJ2506_Architecture_V3.pptx
@@ -3418,12 +3418,12 @@
           <a:p>
             <a:pPr>
               <a:lnSpc>
-                <a:spcPct val="120000"/>
+                <a:spcPct val="110000"/>
               </a:lnSpc>
               <a:spcBef>
-                <a:spcPts val="800"/>
+                <a:spcPts val="500"/>
               </a:spcBef>
-              <a:defRPr sz="2800" b="1">
+              <a:defRPr sz="2200" b="1">
                 <a:solidFill>
                   <a:srgbClr val="0066CC"/>
                 </a:solidFill>
@@ -3437,12 +3437,12 @@
           <a:p>
             <a:pPr lvl="1">
               <a:lnSpc>
-                <a:spcPct val="120000"/>
+                <a:spcPct val="110000"/>
               </a:lnSpc>
               <a:spcBef>
-                <a:spcPts val="800"/>
+                <a:spcPts val="500"/>
               </a:spcBef>
-              <a:defRPr sz="2400" b="1">
+              <a:defRPr sz="1900" b="1">
                 <a:solidFill>
                   <a:srgbClr val="FF6600"/>
                 </a:solidFill>
@@ -3456,12 +3456,12 @@
           <a:p>
             <a:pPr lvl="1">
               <a:lnSpc>
-                <a:spcPct val="120000"/>
+                <a:spcPct val="110000"/>
               </a:lnSpc>
               <a:spcBef>
-                <a:spcPts val="800"/>
+                <a:spcPts val="500"/>
               </a:spcBef>
-              <a:defRPr sz="2400" b="0">
+              <a:defRPr sz="1900" b="1">
                 <a:solidFill>
                   <a:srgbClr val="333333"/>
                 </a:solidFill>
@@ -3469,7 +3469,159 @@
               </a:defRPr>
             </a:pPr>
             <a:r>
-              <a:t>任务: Sim2Real数据采集与训练、模型部署、实车打通与联调</a:t>
+              <a:t>核心任务列表:</a:t>
+            </a:r>
+          </a:p>
+          <a:p>
+            <a:pPr lvl="2">
+              <a:lnSpc>
+                <a:spcPct val="110000"/>
+              </a:lnSpc>
+              <a:spcBef>
+                <a:spcPts val="500"/>
+              </a:spcBef>
+              <a:defRPr sz="1600" b="1">
+                <a:solidFill>
+                  <a:srgbClr val="003366"/>
+                </a:solidFill>
+                <a:latin typeface="Microsoft YaHei"/>
+              </a:defRPr>
+            </a:pPr>
+            <a:r>
+              <a:t>[2.1] 数据采集与 Sim2Real</a:t>
+            </a:r>
+          </a:p>
+          <a:p>
+            <a:pPr lvl="3">
+              <a:lnSpc>
+                <a:spcPct val="110000"/>
+              </a:lnSpc>
+              <a:spcBef>
+                <a:spcPts val="500"/>
+              </a:spcBef>
+              <a:defRPr sz="1300" b="0">
+                <a:solidFill>
+                  <a:srgbClr val="333333"/>
+                </a:solidFill>
+                <a:latin typeface="Microsoft YaHei"/>
+              </a:defRPr>
+            </a:pPr>
+            <a:r>
+              <a:t>• 录制 50 条遥操作真机数据，导入 IsaacLab</a:t>
+            </a:r>
+          </a:p>
+          <a:p>
+            <a:pPr lvl="3">
+              <a:lnSpc>
+                <a:spcPct val="110000"/>
+              </a:lnSpc>
+              <a:spcBef>
+                <a:spcPts val="500"/>
+              </a:spcBef>
+              <a:defRPr sz="1300" b="0">
+                <a:solidFill>
+                  <a:srgbClr val="333333"/>
+                </a:solidFill>
+                <a:latin typeface="Microsoft YaHei"/>
+              </a:defRPr>
+            </a:pPr>
+            <a:r>
+              <a:t>• 生成 10000 条带各种光照变异的合成数据进行扩充</a:t>
+            </a:r>
+          </a:p>
+          <a:p>
+            <a:pPr lvl="2">
+              <a:lnSpc>
+                <a:spcPct val="110000"/>
+              </a:lnSpc>
+              <a:spcBef>
+                <a:spcPts val="500"/>
+              </a:spcBef>
+              <a:defRPr sz="1600" b="1">
+                <a:solidFill>
+                  <a:srgbClr val="003366"/>
+                </a:solidFill>
+                <a:latin typeface="Microsoft YaHei"/>
+              </a:defRPr>
+            </a:pPr>
+            <a:r>
+              <a:t>[2.2] DP 模型训练与 TensorRT 部署</a:t>
+            </a:r>
+          </a:p>
+          <a:p>
+            <a:pPr lvl="3">
+              <a:lnSpc>
+                <a:spcPct val="110000"/>
+              </a:lnSpc>
+              <a:spcBef>
+                <a:spcPts val="500"/>
+              </a:spcBef>
+              <a:defRPr sz="1300" b="0">
+                <a:solidFill>
+                  <a:srgbClr val="333333"/>
+                </a:solidFill>
+                <a:latin typeface="Microsoft YaHei"/>
+              </a:defRPr>
+            </a:pPr>
+            <a:r>
+              <a:t>• 在 H100 集群上完成 Diffusion Policy 训练</a:t>
+            </a:r>
+          </a:p>
+          <a:p>
+            <a:pPr lvl="3">
+              <a:lnSpc>
+                <a:spcPct val="110000"/>
+              </a:lnSpc>
+              <a:spcBef>
+                <a:spcPts val="500"/>
+              </a:spcBef>
+              <a:defRPr sz="1300" b="0">
+                <a:solidFill>
+                  <a:srgbClr val="333333"/>
+                </a:solidFill>
+                <a:latin typeface="Microsoft YaHei"/>
+              </a:defRPr>
+            </a:pPr>
+            <a:r>
+              <a:t>• Orin 边缘端 TensorRT 部署，保证推理延迟 &lt; 30ms</a:t>
+            </a:r>
+          </a:p>
+          <a:p>
+            <a:pPr lvl="2">
+              <a:lnSpc>
+                <a:spcPct val="110000"/>
+              </a:lnSpc>
+              <a:spcBef>
+                <a:spcPts val="500"/>
+              </a:spcBef>
+              <a:defRPr sz="1600" b="1">
+                <a:solidFill>
+                  <a:srgbClr val="003366"/>
+                </a:solidFill>
+                <a:latin typeface="Microsoft YaHei"/>
+              </a:defRPr>
+            </a:pPr>
+            <a:r>
+              <a:t>[2.3] 大脑节点 (Brain Node) 实车串联</a:t>
+            </a:r>
+          </a:p>
+          <a:p>
+            <a:pPr lvl="3">
+              <a:lnSpc>
+                <a:spcPct val="110000"/>
+              </a:lnSpc>
+              <a:spcBef>
+                <a:spcPts val="500"/>
+              </a:spcBef>
+              <a:defRPr sz="1300" b="0">
+                <a:solidFill>
+                  <a:srgbClr val="333333"/>
+                </a:solidFill>
+                <a:latin typeface="Microsoft YaHei"/>
+              </a:defRPr>
+            </a:pPr>
+            <a:r>
+              <a:t>• 将 Nav2 -&gt; ACT -&gt; Feature Memory -&gt; IBVS -&gt; Touch-down 管线在真机完全打通</a:t>
             </a:r>
           </a:p>
         </p:txBody>
@@ -3798,7 +3950,7 @@
           <a:lstStyle/>
           <a:p>
             <a:pPr algn="ctr">
-              <a:defRPr b="1" sz="2200">
+              <a:defRPr b="1" sz="2000">
                 <a:solidFill>
                   <a:srgbClr val="0066CC"/>
                 </a:solidFill>
@@ -3810,7 +3962,7 @@
           </a:p>
           <a:p>
             <a:pPr>
-              <a:defRPr sz="1600">
+              <a:defRPr sz="1400">
                 <a:solidFill>
                   <a:srgbClr val="333333"/>
                 </a:solidFill>
@@ -3868,7 +4020,7 @@
           <a:lstStyle/>
           <a:p>
             <a:pPr algn="ctr">
-              <a:defRPr b="1" sz="2200">
+              <a:defRPr b="1" sz="2000">
                 <a:solidFill>
                   <a:srgbClr val="FF6600"/>
                 </a:solidFill>
@@ -3880,7 +4032,7 @@
           </a:p>
           <a:p>
             <a:pPr>
-              <a:defRPr sz="1600">
+              <a:defRPr sz="1400">
                 <a:solidFill>
                   <a:srgbClr val="333333"/>
                 </a:solidFill>
@@ -4055,12 +4207,12 @@
           <a:p>
             <a:pPr>
               <a:lnSpc>
-                <a:spcPct val="120000"/>
+                <a:spcPct val="110000"/>
               </a:lnSpc>
               <a:spcBef>
-                <a:spcPts val="800"/>
+                <a:spcPts val="500"/>
               </a:spcBef>
-              <a:defRPr sz="2800" b="1">
+              <a:defRPr sz="2200" b="1">
                 <a:solidFill>
                   <a:srgbClr val="003366"/>
                 </a:solidFill>
@@ -4074,12 +4226,12 @@
           <a:p>
             <a:pPr lvl="1">
               <a:lnSpc>
-                <a:spcPct val="120000"/>
+                <a:spcPct val="110000"/>
               </a:lnSpc>
               <a:spcBef>
-                <a:spcPts val="800"/>
+                <a:spcPts val="500"/>
               </a:spcBef>
-              <a:defRPr sz="2400" b="0">
+              <a:defRPr sz="1900" b="0">
                 <a:solidFill>
                   <a:srgbClr val="333333"/>
                 </a:solidFill>
@@ -4093,12 +4245,12 @@
           <a:p>
             <a:pPr lvl="1">
               <a:lnSpc>
-                <a:spcPct val="120000"/>
+                <a:spcPct val="110000"/>
               </a:lnSpc>
               <a:spcBef>
-                <a:spcPts val="800"/>
+                <a:spcPts val="500"/>
               </a:spcBef>
-              <a:defRPr sz="2400" b="0">
+              <a:defRPr sz="1900" b="0">
                 <a:solidFill>
                   <a:srgbClr val="333333"/>
                 </a:solidFill>
@@ -4112,12 +4264,12 @@
           <a:p>
             <a:pPr lvl="1">
               <a:lnSpc>
-                <a:spcPct val="120000"/>
+                <a:spcPct val="110000"/>
               </a:lnSpc>
               <a:spcBef>
-                <a:spcPts val="800"/>
+                <a:spcPts val="500"/>
               </a:spcBef>
-              <a:defRPr sz="2400" b="0">
+              <a:defRPr sz="1900" b="0">
                 <a:solidFill>
                   <a:srgbClr val="333333"/>
                 </a:solidFill>
@@ -4131,12 +4283,12 @@
           <a:p>
             <a:pPr lvl="1">
               <a:lnSpc>
-                <a:spcPct val="120000"/>
+                <a:spcPct val="110000"/>
               </a:lnSpc>
               <a:spcBef>
-                <a:spcPts val="800"/>
+                <a:spcPts val="500"/>
               </a:spcBef>
-              <a:defRPr sz="2400" b="0">
+              <a:defRPr sz="1900" b="0">
                 <a:solidFill>
                   <a:srgbClr val="333333"/>
                 </a:solidFill>
@@ -4150,12 +4302,12 @@
           <a:p>
             <a:pPr>
               <a:lnSpc>
-                <a:spcPct val="120000"/>
+                <a:spcPct val="110000"/>
               </a:lnSpc>
               <a:spcBef>
-                <a:spcPts val="800"/>
+                <a:spcPts val="500"/>
               </a:spcBef>
-              <a:defRPr sz="2800" b="1">
+              <a:defRPr sz="2200" b="1">
                 <a:solidFill>
                   <a:srgbClr val="003366"/>
                 </a:solidFill>
@@ -4169,12 +4321,12 @@
           <a:p>
             <a:pPr lvl="1">
               <a:lnSpc>
-                <a:spcPct val="120000"/>
+                <a:spcPct val="110000"/>
               </a:lnSpc>
               <a:spcBef>
-                <a:spcPts val="800"/>
+                <a:spcPts val="500"/>
               </a:spcBef>
-              <a:defRPr sz="2400" b="0">
+              <a:defRPr sz="1900" b="0">
                 <a:solidFill>
                   <a:srgbClr val="333333"/>
                 </a:solidFill>
@@ -4188,12 +4340,12 @@
           <a:p>
             <a:pPr lvl="1">
               <a:lnSpc>
-                <a:spcPct val="120000"/>
+                <a:spcPct val="110000"/>
               </a:lnSpc>
               <a:spcBef>
-                <a:spcPts val="800"/>
+                <a:spcPts val="500"/>
               </a:spcBef>
-              <a:defRPr sz="2400" b="0">
+              <a:defRPr sz="1900" b="0">
                 <a:solidFill>
                   <a:srgbClr val="333333"/>
                 </a:solidFill>
@@ -4207,12 +4359,12 @@
           <a:p>
             <a:pPr>
               <a:lnSpc>
-                <a:spcPct val="120000"/>
+                <a:spcPct val="110000"/>
               </a:lnSpc>
               <a:spcBef>
-                <a:spcPts val="800"/>
+                <a:spcPts val="500"/>
               </a:spcBef>
-              <a:defRPr sz="2800" b="1">
+              <a:defRPr sz="2200" b="1">
                 <a:solidFill>
                   <a:srgbClr val="FF6600"/>
                 </a:solidFill>
@@ -4226,12 +4378,12 @@
           <a:p>
             <a:pPr lvl="1">
               <a:lnSpc>
-                <a:spcPct val="120000"/>
+                <a:spcPct val="110000"/>
               </a:lnSpc>
               <a:spcBef>
-                <a:spcPts val="800"/>
+                <a:spcPts val="500"/>
               </a:spcBef>
-              <a:defRPr sz="2400" b="0">
+              <a:defRPr sz="1900" b="0">
                 <a:solidFill>
                   <a:srgbClr val="333333"/>
                 </a:solidFill>
@@ -4245,12 +4397,12 @@
           <a:p>
             <a:pPr lvl="1">
               <a:lnSpc>
-                <a:spcPct val="120000"/>
+                <a:spcPct val="110000"/>
               </a:lnSpc>
               <a:spcBef>
-                <a:spcPts val="800"/>
+                <a:spcPts val="500"/>
               </a:spcBef>
-              <a:defRPr sz="2400" b="0">
+              <a:defRPr sz="1900" b="0">
                 <a:solidFill>
                   <a:srgbClr val="333333"/>
                 </a:solidFill>
@@ -5265,12 +5417,12 @@
           <a:p>
             <a:pPr>
               <a:lnSpc>
-                <a:spcPct val="120000"/>
+                <a:spcPct val="110000"/>
               </a:lnSpc>
               <a:spcBef>
-                <a:spcPts val="800"/>
+                <a:spcPts val="500"/>
               </a:spcBef>
-              <a:defRPr sz="2800" b="0">
+              <a:defRPr sz="2200" b="0">
                 <a:solidFill>
                   <a:srgbClr val="333333"/>
                 </a:solidFill>
@@ -5281,12 +5433,12 @@
           <a:p>
             <a:pPr lvl="1">
               <a:lnSpc>
-                <a:spcPct val="120000"/>
+                <a:spcPct val="110000"/>
               </a:lnSpc>
               <a:spcBef>
-                <a:spcPts val="800"/>
+                <a:spcPts val="500"/>
               </a:spcBef>
-              <a:defRPr sz="2400" b="1">
+              <a:defRPr sz="1900" b="1">
                 <a:solidFill>
                   <a:srgbClr val="333333"/>
                 </a:solidFill>
@@ -5300,12 +5452,12 @@
           <a:p>
             <a:pPr lvl="2">
               <a:lnSpc>
-                <a:spcPct val="120000"/>
+                <a:spcPct val="110000"/>
               </a:lnSpc>
               <a:spcBef>
-                <a:spcPts val="800"/>
+                <a:spcPts val="500"/>
               </a:spcBef>
-              <a:defRPr sz="2000" b="0">
+              <a:defRPr sz="1600" b="0">
                 <a:solidFill>
                   <a:srgbClr val="333333"/>
                 </a:solidFill>
@@ -5319,12 +5471,12 @@
           <a:p>
             <a:pPr lvl="1">
               <a:lnSpc>
-                <a:spcPct val="120000"/>
+                <a:spcPct val="110000"/>
               </a:lnSpc>
               <a:spcBef>
-                <a:spcPts val="800"/>
+                <a:spcPts val="500"/>
               </a:spcBef>
-              <a:defRPr sz="2400" b="1">
+              <a:defRPr sz="1900" b="1">
                 <a:solidFill>
                   <a:srgbClr val="333333"/>
                 </a:solidFill>
@@ -5338,12 +5490,12 @@
           <a:p>
             <a:pPr lvl="2">
               <a:lnSpc>
-                <a:spcPct val="120000"/>
+                <a:spcPct val="110000"/>
               </a:lnSpc>
               <a:spcBef>
-                <a:spcPts val="800"/>
+                <a:spcPts val="500"/>
               </a:spcBef>
-              <a:defRPr sz="2000" b="0">
+              <a:defRPr sz="1600" b="0">
                 <a:solidFill>
                   <a:srgbClr val="333333"/>
                 </a:solidFill>
@@ -5357,12 +5509,12 @@
           <a:p>
             <a:pPr lvl="1">
               <a:lnSpc>
-                <a:spcPct val="120000"/>
+                <a:spcPct val="110000"/>
               </a:lnSpc>
               <a:spcBef>
-                <a:spcPts val="800"/>
+                <a:spcPts val="500"/>
               </a:spcBef>
-              <a:defRPr sz="2400" b="1">
+              <a:defRPr sz="1900" b="1">
                 <a:solidFill>
                   <a:srgbClr val="333333"/>
                 </a:solidFill>
@@ -5376,12 +5528,12 @@
           <a:p>
             <a:pPr lvl="2">
               <a:lnSpc>
-                <a:spcPct val="120000"/>
+                <a:spcPct val="110000"/>
               </a:lnSpc>
               <a:spcBef>
-                <a:spcPts val="800"/>
+                <a:spcPts val="500"/>
               </a:spcBef>
-              <a:defRPr sz="2000" b="0">
+              <a:defRPr sz="1600" b="0">
                 <a:solidFill>
                   <a:srgbClr val="333333"/>
                 </a:solidFill>
@@ -5487,12 +5639,12 @@
           <a:p>
             <a:pPr>
               <a:lnSpc>
-                <a:spcPct val="120000"/>
+                <a:spcPct val="110000"/>
               </a:lnSpc>
               <a:spcBef>
-                <a:spcPts val="800"/>
+                <a:spcPts val="500"/>
               </a:spcBef>
-              <a:defRPr sz="2800" b="0">
+              <a:defRPr sz="2200" b="0">
                 <a:solidFill>
                   <a:srgbClr val="333333"/>
                 </a:solidFill>
@@ -5503,12 +5655,12 @@
           <a:p>
             <a:pPr lvl="1">
               <a:lnSpc>
-                <a:spcPct val="120000"/>
+                <a:spcPct val="110000"/>
               </a:lnSpc>
               <a:spcBef>
-                <a:spcPts val="800"/>
+                <a:spcPts val="500"/>
               </a:spcBef>
-              <a:defRPr sz="2400" b="1">
+              <a:defRPr sz="1900" b="1">
                 <a:solidFill>
                   <a:srgbClr val="333333"/>
                 </a:solidFill>
@@ -5522,12 +5674,12 @@
           <a:p>
             <a:pPr lvl="2">
               <a:lnSpc>
-                <a:spcPct val="120000"/>
+                <a:spcPct val="110000"/>
               </a:lnSpc>
               <a:spcBef>
-                <a:spcPts val="800"/>
+                <a:spcPts val="500"/>
               </a:spcBef>
-              <a:defRPr sz="2000" b="0">
+              <a:defRPr sz="1600" b="0">
                 <a:solidFill>
                   <a:srgbClr val="333333"/>
                 </a:solidFill>
@@ -5541,12 +5693,12 @@
           <a:p>
             <a:pPr lvl="1">
               <a:lnSpc>
-                <a:spcPct val="120000"/>
+                <a:spcPct val="110000"/>
               </a:lnSpc>
               <a:spcBef>
-                <a:spcPts val="800"/>
+                <a:spcPts val="500"/>
               </a:spcBef>
-              <a:defRPr sz="2400" b="1">
+              <a:defRPr sz="1900" b="1">
                 <a:solidFill>
                   <a:srgbClr val="333333"/>
                 </a:solidFill>
@@ -5560,12 +5712,12 @@
           <a:p>
             <a:pPr lvl="2">
               <a:lnSpc>
-                <a:spcPct val="120000"/>
+                <a:spcPct val="110000"/>
               </a:lnSpc>
               <a:spcBef>
-                <a:spcPts val="800"/>
+                <a:spcPts val="500"/>
               </a:spcBef>
-              <a:defRPr sz="2000" b="0">
+              <a:defRPr sz="1600" b="0">
                 <a:solidFill>
                   <a:srgbClr val="333333"/>
                 </a:solidFill>
@@ -5579,12 +5731,12 @@
           <a:p>
             <a:pPr lvl="1">
               <a:lnSpc>
-                <a:spcPct val="120000"/>
+                <a:spcPct val="110000"/>
               </a:lnSpc>
               <a:spcBef>
-                <a:spcPts val="800"/>
+                <a:spcPts val="500"/>
               </a:spcBef>
-              <a:defRPr sz="2400" b="1">
+              <a:defRPr sz="1900" b="1">
                 <a:solidFill>
                   <a:srgbClr val="333333"/>
                 </a:solidFill>
@@ -5598,12 +5750,12 @@
           <a:p>
             <a:pPr lvl="2">
               <a:lnSpc>
-                <a:spcPct val="120000"/>
+                <a:spcPct val="110000"/>
               </a:lnSpc>
               <a:spcBef>
-                <a:spcPts val="800"/>
+                <a:spcPts val="500"/>
               </a:spcBef>
-              <a:defRPr sz="2000" b="0">
+              <a:defRPr sz="1600" b="0">
                 <a:solidFill>
                   <a:srgbClr val="333333"/>
                 </a:solidFill>
@@ -5775,12 +5927,12 @@
           <a:p>
             <a:pPr>
               <a:lnSpc>
-                <a:spcPct val="120000"/>
+                <a:spcPct val="110000"/>
               </a:lnSpc>
               <a:spcBef>
-                <a:spcPts val="800"/>
+                <a:spcPts val="500"/>
               </a:spcBef>
-              <a:defRPr sz="2800" b="1">
+              <a:defRPr sz="2200" b="1">
                 <a:solidFill>
                   <a:srgbClr val="0066CC"/>
                 </a:solidFill>
@@ -5794,12 +5946,12 @@
           <a:p>
             <a:pPr lvl="1">
               <a:lnSpc>
-                <a:spcPct val="120000"/>
+                <a:spcPct val="110000"/>
               </a:lnSpc>
               <a:spcBef>
-                <a:spcPts val="800"/>
+                <a:spcPts val="500"/>
               </a:spcBef>
-              <a:defRPr sz="2400" b="0">
+              <a:defRPr sz="1900" b="0">
                 <a:solidFill>
                   <a:srgbClr val="333333"/>
                 </a:solidFill>
@@ -5813,12 +5965,12 @@
           <a:p>
             <a:pPr lvl="1">
               <a:lnSpc>
-                <a:spcPct val="120000"/>
+                <a:spcPct val="110000"/>
               </a:lnSpc>
               <a:spcBef>
-                <a:spcPts val="800"/>
+                <a:spcPts val="500"/>
               </a:spcBef>
-              <a:defRPr sz="2400" b="0">
+              <a:defRPr sz="1900" b="0">
                 <a:solidFill>
                   <a:srgbClr val="333333"/>
                 </a:solidFill>
@@ -5832,12 +5984,12 @@
           <a:p>
             <a:pPr lvl="1">
               <a:lnSpc>
-                <a:spcPct val="120000"/>
+                <a:spcPct val="110000"/>
               </a:lnSpc>
               <a:spcBef>
-                <a:spcPts val="800"/>
+                <a:spcPts val="500"/>
               </a:spcBef>
-              <a:defRPr sz="2400" b="0">
+              <a:defRPr sz="1900" b="0">
                 <a:solidFill>
                   <a:srgbClr val="333333"/>
                 </a:solidFill>
@@ -5851,12 +6003,12 @@
           <a:p>
             <a:pPr>
               <a:lnSpc>
-                <a:spcPct val="120000"/>
+                <a:spcPct val="110000"/>
               </a:lnSpc>
               <a:spcBef>
-                <a:spcPts val="800"/>
+                <a:spcPts val="500"/>
               </a:spcBef>
-              <a:defRPr sz="2800" b="0">
+              <a:defRPr sz="2200" b="0">
                 <a:solidFill>
                   <a:srgbClr val="333333"/>
                 </a:solidFill>
@@ -5867,12 +6019,12 @@
           <a:p>
             <a:pPr>
               <a:lnSpc>
-                <a:spcPct val="120000"/>
+                <a:spcPct val="110000"/>
               </a:lnSpc>
               <a:spcBef>
-                <a:spcPts val="800"/>
+                <a:spcPts val="500"/>
               </a:spcBef>
-              <a:defRPr sz="2800" b="1">
+              <a:defRPr sz="2200" b="1">
                 <a:solidFill>
                   <a:srgbClr val="0066CC"/>
                 </a:solidFill>
@@ -5886,12 +6038,12 @@
           <a:p>
             <a:pPr lvl="1">
               <a:lnSpc>
-                <a:spcPct val="120000"/>
+                <a:spcPct val="110000"/>
               </a:lnSpc>
               <a:spcBef>
-                <a:spcPts val="800"/>
+                <a:spcPts val="500"/>
               </a:spcBef>
-              <a:defRPr sz="2400" b="0">
+              <a:defRPr sz="1900" b="0">
                 <a:solidFill>
                   <a:srgbClr val="333333"/>
                 </a:solidFill>
@@ -5905,12 +6057,12 @@
           <a:p>
             <a:pPr lvl="1">
               <a:lnSpc>
-                <a:spcPct val="120000"/>
+                <a:spcPct val="110000"/>
               </a:lnSpc>
               <a:spcBef>
-                <a:spcPts val="800"/>
+                <a:spcPts val="500"/>
               </a:spcBef>
-              <a:defRPr sz="2400" b="0">
+              <a:defRPr sz="1900" b="0">
                 <a:solidFill>
                   <a:srgbClr val="333333"/>
                 </a:solidFill>
@@ -5924,12 +6076,12 @@
           <a:p>
             <a:pPr lvl="1">
               <a:lnSpc>
-                <a:spcPct val="120000"/>
+                <a:spcPct val="110000"/>
               </a:lnSpc>
               <a:spcBef>
-                <a:spcPts val="800"/>
+                <a:spcPts val="500"/>
               </a:spcBef>
-              <a:defRPr sz="2400" b="0">
+              <a:defRPr sz="1900" b="0">
                 <a:solidFill>
                   <a:srgbClr val="333333"/>
                 </a:solidFill>
@@ -5943,12 +6095,12 @@
           <a:p>
             <a:pPr>
               <a:lnSpc>
-                <a:spcPct val="120000"/>
+                <a:spcPct val="110000"/>
               </a:lnSpc>
               <a:spcBef>
-                <a:spcPts val="800"/>
+                <a:spcPts val="500"/>
               </a:spcBef>
-              <a:defRPr sz="2800" b="0">
+              <a:defRPr sz="2200" b="0">
                 <a:solidFill>
                   <a:srgbClr val="333333"/>
                 </a:solidFill>
@@ -5959,12 +6111,12 @@
           <a:p>
             <a:pPr>
               <a:lnSpc>
-                <a:spcPct val="120000"/>
+                <a:spcPct val="110000"/>
               </a:lnSpc>
               <a:spcBef>
-                <a:spcPts val="800"/>
+                <a:spcPts val="500"/>
               </a:spcBef>
-              <a:defRPr sz="2800" b="1">
+              <a:defRPr sz="2200" b="1">
                 <a:solidFill>
                   <a:srgbClr val="0066CC"/>
                 </a:solidFill>
@@ -5978,12 +6130,12 @@
           <a:p>
             <a:pPr lvl="1">
               <a:lnSpc>
-                <a:spcPct val="120000"/>
+                <a:spcPct val="110000"/>
               </a:lnSpc>
               <a:spcBef>
-                <a:spcPts val="800"/>
+                <a:spcPts val="500"/>
               </a:spcBef>
-              <a:defRPr sz="2400" b="0">
+              <a:defRPr sz="1900" b="0">
                 <a:solidFill>
                   <a:srgbClr val="333333"/>
                 </a:solidFill>
@@ -5997,12 +6149,12 @@
           <a:p>
             <a:pPr lvl="1">
               <a:lnSpc>
-                <a:spcPct val="120000"/>
+                <a:spcPct val="110000"/>
               </a:lnSpc>
               <a:spcBef>
-                <a:spcPts val="800"/>
+                <a:spcPts val="500"/>
               </a:spcBef>
-              <a:defRPr sz="2400" b="0">
+              <a:defRPr sz="1900" b="0">
                 <a:solidFill>
                   <a:srgbClr val="333333"/>
                 </a:solidFill>
@@ -6174,12 +6326,12 @@
           <a:p>
             <a:pPr>
               <a:lnSpc>
-                <a:spcPct val="120000"/>
+                <a:spcPct val="110000"/>
               </a:lnSpc>
               <a:spcBef>
-                <a:spcPts val="800"/>
+                <a:spcPts val="500"/>
               </a:spcBef>
-              <a:defRPr sz="2800" b="1">
+              <a:defRPr sz="2200" b="1">
                 <a:solidFill>
                   <a:srgbClr val="0066CC"/>
                 </a:solidFill>
@@ -6193,12 +6345,12 @@
           <a:p>
             <a:pPr lvl="1">
               <a:lnSpc>
-                <a:spcPct val="120000"/>
+                <a:spcPct val="110000"/>
               </a:lnSpc>
               <a:spcBef>
-                <a:spcPts val="800"/>
+                <a:spcPts val="500"/>
               </a:spcBef>
-              <a:defRPr sz="2400" b="0">
+              <a:defRPr sz="1900" b="0">
                 <a:solidFill>
                   <a:srgbClr val="333333"/>
                 </a:solidFill>
@@ -6212,12 +6364,12 @@
           <a:p>
             <a:pPr lvl="1">
               <a:lnSpc>
-                <a:spcPct val="120000"/>
+                <a:spcPct val="110000"/>
               </a:lnSpc>
               <a:spcBef>
-                <a:spcPts val="800"/>
+                <a:spcPts val="500"/>
               </a:spcBef>
-              <a:defRPr sz="2400" b="0">
+              <a:defRPr sz="1900" b="0">
                 <a:solidFill>
                   <a:srgbClr val="333333"/>
                 </a:solidFill>
@@ -6231,12 +6383,12 @@
           <a:p>
             <a:pPr lvl="1">
               <a:lnSpc>
-                <a:spcPct val="120000"/>
+                <a:spcPct val="110000"/>
               </a:lnSpc>
               <a:spcBef>
-                <a:spcPts val="800"/>
+                <a:spcPts val="500"/>
               </a:spcBef>
-              <a:defRPr sz="2400" b="0">
+              <a:defRPr sz="1900" b="0">
                 <a:solidFill>
                   <a:srgbClr val="333333"/>
                 </a:solidFill>
@@ -6250,12 +6402,12 @@
           <a:p>
             <a:pPr>
               <a:lnSpc>
-                <a:spcPct val="120000"/>
+                <a:spcPct val="110000"/>
               </a:lnSpc>
               <a:spcBef>
-                <a:spcPts val="800"/>
+                <a:spcPts val="500"/>
               </a:spcBef>
-              <a:defRPr sz="2800" b="0">
+              <a:defRPr sz="2200" b="0">
                 <a:solidFill>
                   <a:srgbClr val="333333"/>
                 </a:solidFill>
@@ -6266,12 +6418,12 @@
           <a:p>
             <a:pPr>
               <a:lnSpc>
-                <a:spcPct val="120000"/>
+                <a:spcPct val="110000"/>
               </a:lnSpc>
               <a:spcBef>
-                <a:spcPts val="800"/>
+                <a:spcPts val="500"/>
               </a:spcBef>
-              <a:defRPr sz="2800" b="1">
+              <a:defRPr sz="2200" b="1">
                 <a:solidFill>
                   <a:srgbClr val="0066CC"/>
                 </a:solidFill>
@@ -6285,12 +6437,12 @@
           <a:p>
             <a:pPr lvl="1">
               <a:lnSpc>
-                <a:spcPct val="120000"/>
+                <a:spcPct val="110000"/>
               </a:lnSpc>
               <a:spcBef>
-                <a:spcPts val="800"/>
+                <a:spcPts val="500"/>
               </a:spcBef>
-              <a:defRPr sz="2400" b="0">
+              <a:defRPr sz="1900" b="0">
                 <a:solidFill>
                   <a:srgbClr val="333333"/>
                 </a:solidFill>
@@ -6304,12 +6456,12 @@
           <a:p>
             <a:pPr lvl="1">
               <a:lnSpc>
-                <a:spcPct val="120000"/>
+                <a:spcPct val="110000"/>
               </a:lnSpc>
               <a:spcBef>
-                <a:spcPts val="800"/>
+                <a:spcPts val="500"/>
               </a:spcBef>
-              <a:defRPr sz="2400" b="0">
+              <a:defRPr sz="1900" b="0">
                 <a:solidFill>
                   <a:srgbClr val="333333"/>
                 </a:solidFill>
@@ -6323,12 +6475,12 @@
           <a:p>
             <a:pPr lvl="1">
               <a:lnSpc>
-                <a:spcPct val="120000"/>
+                <a:spcPct val="110000"/>
               </a:lnSpc>
               <a:spcBef>
-                <a:spcPts val="800"/>
+                <a:spcPts val="500"/>
               </a:spcBef>
-              <a:defRPr sz="2400" b="0">
+              <a:defRPr sz="1900" b="0">
                 <a:solidFill>
                   <a:srgbClr val="333333"/>
                 </a:solidFill>
@@ -6342,12 +6494,12 @@
           <a:p>
             <a:pPr>
               <a:lnSpc>
-                <a:spcPct val="120000"/>
+                <a:spcPct val="110000"/>
               </a:lnSpc>
               <a:spcBef>
-                <a:spcPts val="800"/>
+                <a:spcPts val="500"/>
               </a:spcBef>
-              <a:defRPr sz="2800" b="0">
+              <a:defRPr sz="2200" b="0">
                 <a:solidFill>
                   <a:srgbClr val="333333"/>
                 </a:solidFill>
@@ -6358,12 +6510,12 @@
           <a:p>
             <a:pPr>
               <a:lnSpc>
-                <a:spcPct val="120000"/>
+                <a:spcPct val="110000"/>
               </a:lnSpc>
               <a:spcBef>
-                <a:spcPts val="800"/>
+                <a:spcPts val="500"/>
               </a:spcBef>
-              <a:defRPr sz="2800" b="1">
+              <a:defRPr sz="2200" b="1">
                 <a:solidFill>
                   <a:srgbClr val="0066CC"/>
                 </a:solidFill>
@@ -6377,12 +6529,12 @@
           <a:p>
             <a:pPr lvl="1">
               <a:lnSpc>
-                <a:spcPct val="120000"/>
+                <a:spcPct val="110000"/>
               </a:lnSpc>
               <a:spcBef>
-                <a:spcPts val="800"/>
+                <a:spcPts val="500"/>
               </a:spcBef>
-              <a:defRPr sz="2400" b="0">
+              <a:defRPr sz="1900" b="0">
                 <a:solidFill>
                   <a:srgbClr val="333333"/>
                 </a:solidFill>
@@ -6396,12 +6548,12 @@
           <a:p>
             <a:pPr lvl="1">
               <a:lnSpc>
-                <a:spcPct val="120000"/>
+                <a:spcPct val="110000"/>
               </a:lnSpc>
               <a:spcBef>
-                <a:spcPts val="800"/>
+                <a:spcPts val="500"/>
               </a:spcBef>
-              <a:defRPr sz="2400" b="0">
+              <a:defRPr sz="1900" b="0">
                 <a:solidFill>
                   <a:srgbClr val="333333"/>
                 </a:solidFill>
@@ -6573,12 +6725,12 @@
           <a:p>
             <a:pPr>
               <a:lnSpc>
-                <a:spcPct val="120000"/>
+                <a:spcPct val="110000"/>
               </a:lnSpc>
               <a:spcBef>
-                <a:spcPts val="800"/>
+                <a:spcPts val="500"/>
               </a:spcBef>
-              <a:defRPr sz="2800" b="1">
+              <a:defRPr sz="2200" b="1">
                 <a:solidFill>
                   <a:srgbClr val="0066CC"/>
                 </a:solidFill>
@@ -6592,12 +6744,12 @@
           <a:p>
             <a:pPr lvl="1">
               <a:lnSpc>
-                <a:spcPct val="120000"/>
+                <a:spcPct val="110000"/>
               </a:lnSpc>
               <a:spcBef>
-                <a:spcPts val="800"/>
+                <a:spcPts val="500"/>
               </a:spcBef>
-              <a:defRPr sz="2400" b="1">
+              <a:defRPr sz="1900" b="1">
                 <a:solidFill>
                   <a:srgbClr val="FF6600"/>
                 </a:solidFill>
@@ -6611,12 +6763,12 @@
           <a:p>
             <a:pPr lvl="1">
               <a:lnSpc>
-                <a:spcPct val="120000"/>
+                <a:spcPct val="110000"/>
               </a:lnSpc>
               <a:spcBef>
-                <a:spcPts val="800"/>
+                <a:spcPts val="500"/>
               </a:spcBef>
-              <a:defRPr sz="2400" b="0">
+              <a:defRPr sz="1900" b="0">
                 <a:solidFill>
                   <a:srgbClr val="333333"/>
                 </a:solidFill>
@@ -6630,12 +6782,12 @@
           <a:p>
             <a:pPr lvl="1">
               <a:lnSpc>
-                <a:spcPct val="120000"/>
+                <a:spcPct val="110000"/>
               </a:lnSpc>
               <a:spcBef>
-                <a:spcPts val="800"/>
+                <a:spcPts val="500"/>
               </a:spcBef>
-              <a:defRPr sz="2400" b="0">
+              <a:defRPr sz="1900" b="0">
                 <a:solidFill>
                   <a:srgbClr val="333333"/>
                 </a:solidFill>
@@ -6807,12 +6959,12 @@
           <a:p>
             <a:pPr>
               <a:lnSpc>
-                <a:spcPct val="120000"/>
+                <a:spcPct val="110000"/>
               </a:lnSpc>
               <a:spcBef>
-                <a:spcPts val="800"/>
+                <a:spcPts val="500"/>
               </a:spcBef>
-              <a:defRPr sz="2800" b="1">
+              <a:defRPr sz="2200" b="1">
                 <a:solidFill>
                   <a:srgbClr val="0066CC"/>
                 </a:solidFill>
@@ -6826,12 +6978,12 @@
           <a:p>
             <a:pPr lvl="1">
               <a:lnSpc>
-                <a:spcPct val="120000"/>
+                <a:spcPct val="110000"/>
               </a:lnSpc>
               <a:spcBef>
-                <a:spcPts val="800"/>
+                <a:spcPts val="500"/>
               </a:spcBef>
-              <a:defRPr sz="2400" b="1">
+              <a:defRPr sz="1900" b="1">
                 <a:solidFill>
                   <a:srgbClr val="FF6600"/>
                 </a:solidFill>
@@ -6845,12 +6997,12 @@
           <a:p>
             <a:pPr lvl="1">
               <a:lnSpc>
-                <a:spcPct val="120000"/>
+                <a:spcPct val="110000"/>
               </a:lnSpc>
               <a:spcBef>
-                <a:spcPts val="800"/>
+                <a:spcPts val="500"/>
               </a:spcBef>
-              <a:defRPr sz="2400" b="0">
+              <a:defRPr sz="1900" b="0">
                 <a:solidFill>
                   <a:srgbClr val="333333"/>
                 </a:solidFill>
@@ -6864,12 +7016,12 @@
           <a:p>
             <a:pPr lvl="2">
               <a:lnSpc>
-                <a:spcPct val="120000"/>
+                <a:spcPct val="110000"/>
               </a:lnSpc>
               <a:spcBef>
-                <a:spcPts val="800"/>
+                <a:spcPts val="500"/>
               </a:spcBef>
-              <a:defRPr sz="2000" b="0">
+              <a:defRPr sz="1600" b="0">
                 <a:solidFill>
                   <a:srgbClr val="333333"/>
                 </a:solidFill>
@@ -6883,12 +7035,12 @@
           <a:p>
             <a:pPr lvl="2">
               <a:lnSpc>
-                <a:spcPct val="120000"/>
+                <a:spcPct val="110000"/>
               </a:lnSpc>
               <a:spcBef>
-                <a:spcPts val="800"/>
+                <a:spcPts val="500"/>
               </a:spcBef>
-              <a:defRPr sz="2000" b="0">
+              <a:defRPr sz="1600" b="0">
                 <a:solidFill>
                   <a:srgbClr val="333333"/>
                 </a:solidFill>
@@ -6902,12 +7054,12 @@
           <a:p>
             <a:pPr lvl="2">
               <a:lnSpc>
-                <a:spcPct val="120000"/>
+                <a:spcPct val="110000"/>
               </a:lnSpc>
               <a:spcBef>
-                <a:spcPts val="800"/>
+                <a:spcPts val="500"/>
               </a:spcBef>
-              <a:defRPr sz="2000" b="0">
+              <a:defRPr sz="1600" b="0">
                 <a:solidFill>
                   <a:srgbClr val="333333"/>
                 </a:solidFill>
@@ -6921,12 +7073,12 @@
           <a:p>
             <a:pPr lvl="2">
               <a:lnSpc>
-                <a:spcPct val="120000"/>
+                <a:spcPct val="110000"/>
               </a:lnSpc>
               <a:spcBef>
-                <a:spcPts val="800"/>
+                <a:spcPts val="500"/>
               </a:spcBef>
-              <a:defRPr sz="2000" b="0">
+              <a:defRPr sz="1600" b="0">
                 <a:solidFill>
                   <a:srgbClr val="333333"/>
                 </a:solidFill>
@@ -6940,12 +7092,12 @@
           <a:p>
             <a:pPr lvl="2">
               <a:lnSpc>
-                <a:spcPct val="120000"/>
+                <a:spcPct val="110000"/>
               </a:lnSpc>
               <a:spcBef>
-                <a:spcPts val="800"/>
+                <a:spcPts val="500"/>
               </a:spcBef>
-              <a:defRPr sz="2000" b="0">
+              <a:defRPr sz="1600" b="0">
                 <a:solidFill>
                   <a:srgbClr val="333333"/>
                 </a:solidFill>

</xml_diff>